<commit_message>
Deploying to gh-pages from @ tamanh-oxford/capacity-development@d221aefd7814f17c26e549789a3b1fd6e0f532ce 🚀
</commit_message>
<xml_diff>
--- a/vi/data-frameworks/06-best-practice-data-governance.pptx
+++ b/vi/data-frameworks/06-best-practice-data-governance.pptx
@@ -3526,7 +3526,7 @@
             </a:pPr>
             <a:r>
               <a:rPr/>
-              <a:t>Xác định mục tiêu và chỉ số đo lường rõ ràng.</a:t>
+              <a:t>Xác định mục tiêu và chỉ số đo lường rõ ràng</a:t>
             </a:r>
           </a:p>
         </p:txBody>
@@ -3708,7 +3708,7 @@
             </a:pPr>
             <a:r>
               <a:rPr/>
-              <a:t>Đây là một cuộc đua marathon, không phải cuộc đua nước rút.</a:t>
+              <a:t>Đây là một cuộc đua marathon, không phải cuộc đua nước rút</a:t>
             </a:r>
           </a:p>
         </p:txBody>

</xml_diff>